<commit_message>
Update slide deck with metadata example and field options
Co-Authored-By: Oz <oz-agent@warp.dev>
</commit_message>
<xml_diff>
--- a/docs/secret-template-entry-guide.pptx
+++ b/docs/secret-template-entry-guide.pptx
@@ -11,6 +11,7 @@
     <p:sldId id="259" r:id="rId10"/>
     <p:sldId id="260" r:id="rId11"/>
     <p:sldId id="261" r:id="rId12"/>
+    <p:sldId id="262" r:id="rId13"/>
   </p:sldIdLst>
   <p:sldSz cx="12191695" cy="6858000" type="screen4x3"/>
   <p:notesSz cx="6858000" cy="9144000"/>
@@ -5469,7 +5470,13 @@
               </a:defRPr>
             </a:pPr>
             <a:r>
-              <a:t>Copy/Paste Metadata Note Template</a:t>
+              <a:rPr sz="2600">
+                <a:solidFill>
+                  <a:srgbClr val="ECF5FF"/>
+                </a:solidFill>
+                <a:latin typeface="Aptos Display"/>
+              </a:rPr>
+              <a:t>Metadata Notes Example (copy/edit)</a:t>
             </a:r>
           </a:p>
         </p:txBody>
@@ -5524,124 +5531,112 @@
               </a:defRPr>
             </a:pPr>
             <a:r>
-              <a:t>owner: &lt;team-or-person&gt;</a:t>
-            </a:r>
-          </a:p>
-          <a:p>
-            <a:pPr>
-              <a:defRPr sz="1700">
+              <a:rPr sz="1500">
                 <a:solidFill>
                   <a:srgbClr val="ECF5FF"/>
                 </a:solidFill>
                 <a:latin typeface="Consolas"/>
-              </a:defRPr>
-            </a:pPr>
-            <a:r>
-              <a:t>system: &lt;system-name&gt;</a:t>
-            </a:r>
-          </a:p>
-          <a:p>
-            <a:pPr>
-              <a:defRPr sz="1700">
+              </a:rPr>
+              <a:t>owner: era-estate</a:t>
+            </a:r>
+          </a:p>
+          <a:p>
+            <a:r>
+              <a:rPr sz="1500">
                 <a:solidFill>
                   <a:srgbClr val="ECF5FF"/>
                 </a:solidFill>
                 <a:latin typeface="Consolas"/>
-              </a:defRPr>
-            </a:pPr>
-            <a:r>
-              <a:t>environment: &lt;dev|staging|prod|shared&gt;</a:t>
-            </a:r>
-          </a:p>
-          <a:p>
-            <a:pPr>
-              <a:defRPr sz="1700">
+              </a:rPr>
+              <a:t>system: hermes</a:t>
+            </a:r>
+          </a:p>
+          <a:p>
+            <a:r>
+              <a:rPr sz="1500">
                 <a:solidFill>
                   <a:srgbClr val="ECF5FF"/>
                 </a:solidFill>
                 <a:latin typeface="Consolas"/>
-              </a:defRPr>
-            </a:pPr>
-            <a:r>
-              <a:t>secret_type: &lt;api_key|db_password|token|jwt_secret|encryption_key&gt;</a:t>
-            </a:r>
-          </a:p>
-          <a:p>
-            <a:pPr>
-              <a:defRPr sz="1700">
+              </a:rPr>
+              <a:t>environment: shared</a:t>
+            </a:r>
+          </a:p>
+          <a:p>
+            <a:r>
+              <a:rPr sz="1500">
                 <a:solidFill>
                   <a:srgbClr val="ECF5FF"/>
                 </a:solidFill>
                 <a:latin typeface="Consolas"/>
-              </a:defRPr>
-            </a:pPr>
-            <a:r>
-              <a:t>rotation_url: &lt;provider-rotation-url&gt;</a:t>
-            </a:r>
-          </a:p>
-          <a:p>
-            <a:pPr>
-              <a:defRPr sz="1700">
+              </a:rPr>
+              <a:t>secret_type: api_key</a:t>
+            </a:r>
+          </a:p>
+          <a:p>
+            <a:r>
+              <a:rPr sz="1500">
                 <a:solidFill>
                   <a:srgbClr val="ECF5FF"/>
                 </a:solidFill>
                 <a:latin typeface="Consolas"/>
-              </a:defRPr>
-            </a:pPr>
-            <a:r>
-              <a:t>created_at: &lt;YYYY-MM-DD&gt;</a:t>
-            </a:r>
-          </a:p>
-          <a:p>
-            <a:pPr>
-              <a:defRPr sz="1700">
+              </a:rPr>
+              <a:t>rotation_url: https://openrouter.ai/settings/keys</a:t>
+            </a:r>
+          </a:p>
+          <a:p>
+            <a:r>
+              <a:rPr sz="1500">
                 <a:solidFill>
                   <a:srgbClr val="ECF5FF"/>
                 </a:solidFill>
                 <a:latin typeface="Consolas"/>
-              </a:defRPr>
-            </a:pPr>
-            <a:r>
-              <a:t>last_rotated_at: &lt;YYYY-MM-DD&gt;</a:t>
-            </a:r>
-          </a:p>
-          <a:p>
-            <a:pPr>
-              <a:defRPr sz="1700">
+              </a:rPr>
+              <a:t>created_at: 2026-04-23</a:t>
+            </a:r>
+          </a:p>
+          <a:p>
+            <a:r>
+              <a:rPr sz="1500">
                 <a:solidFill>
                   <a:srgbClr val="ECF5FF"/>
                 </a:solidFill>
                 <a:latin typeface="Consolas"/>
-              </a:defRPr>
-            </a:pPr>
-            <a:r>
-              <a:t>next_rotation_due: &lt;YYYY-MM-DD&gt;</a:t>
-            </a:r>
-          </a:p>
-          <a:p>
-            <a:pPr>
-              <a:defRPr sz="1700">
+              </a:rPr>
+              <a:t>last_rotated_at: 2026-04-23</a:t>
+            </a:r>
+          </a:p>
+          <a:p>
+            <a:r>
+              <a:rPr sz="1500">
                 <a:solidFill>
                   <a:srgbClr val="ECF5FF"/>
                 </a:solidFill>
                 <a:latin typeface="Consolas"/>
-              </a:defRPr>
-            </a:pPr>
-            <a:r>
-              <a:t>incident_rotation_required: &lt;true|false&gt;</a:t>
-            </a:r>
-          </a:p>
-          <a:p>
-            <a:pPr>
-              <a:defRPr sz="1700">
+              </a:rPr>
+              <a:t>next_rotation_due: 2026-07-23</a:t>
+            </a:r>
+          </a:p>
+          <a:p>
+            <a:r>
+              <a:rPr sz="1500">
                 <a:solidFill>
                   <a:srgbClr val="ECF5FF"/>
                 </a:solidFill>
                 <a:latin typeface="Consolas"/>
-              </a:defRPr>
-            </a:pPr>
-            <a:r>
-              <a:t>notes: &lt;free-text&gt;</a:t>
+              </a:rPr>
+              <a:t>incident_rotation_required: false</a:t>
+            </a:r>
+          </a:p>
+          <a:p>
+            <a:r>
+              <a:rPr sz="1500">
+                <a:solidFill>
+                  <a:srgbClr val="ECF5FF"/>
+                </a:solidFill>
+                <a:latin typeface="Consolas"/>
+              </a:rPr>
+              <a:t>notes: Primary OpenRouter key used by Hermes via Varlock; rotate immediately if exposed.</a:t>
             </a:r>
           </a:p>
         </p:txBody>
@@ -5695,67 +5690,544 @@
               </a:defRPr>
             </a:pPr>
             <a:r>
+              <a:rPr sz="1400" b="1">
+                <a:solidFill>
+                  <a:srgbClr val="4ADE80"/>
+                </a:solidFill>
+                <a:latin typeface="Aptos"/>
+              </a:rPr>
               <a:t>Before save:</a:t>
             </a:r>
           </a:p>
           <a:p>
-            <a:pPr>
-              <a:defRPr sz="1700" b="0">
-                <a:solidFill>
-                  <a:srgbClr val="ECF5FF"/>
-                </a:solidFill>
-              </a:defRPr>
-            </a:pPr>
-            <a:r>
-              <a:t>✓ owner</a:t>
-            </a:r>
-          </a:p>
-          <a:p>
-            <a:pPr>
-              <a:defRPr sz="1700" b="0">
-                <a:solidFill>
-                  <a:srgbClr val="ECF5FF"/>
-                </a:solidFill>
-              </a:defRPr>
-            </a:pPr>
-            <a:r>
-              <a:t>✓ system</a:t>
-            </a:r>
-          </a:p>
-          <a:p>
-            <a:pPr>
-              <a:defRPr sz="1700" b="0">
-                <a:solidFill>
-                  <a:srgbClr val="ECF5FF"/>
-                </a:solidFill>
-              </a:defRPr>
-            </a:pPr>
-            <a:r>
-              <a:t>✓ rotation_url</a:t>
-            </a:r>
-          </a:p>
-          <a:p>
-            <a:pPr>
-              <a:defRPr sz="1700" b="0">
-                <a:solidFill>
-                  <a:srgbClr val="ECF5FF"/>
-                </a:solidFill>
-              </a:defRPr>
-            </a:pPr>
-            <a:r>
-              <a:t>✓ dates</a:t>
-            </a:r>
-          </a:p>
-          <a:p>
-            <a:pPr>
-              <a:defRPr sz="1700" b="0">
-                <a:solidFill>
-                  <a:srgbClr val="ECF5FF"/>
-                </a:solidFill>
-              </a:defRPr>
-            </a:pPr>
-            <a:r>
-              <a:t>✓ notes</a:t>
+            <a:r>
+              <a:rPr sz="1400">
+                <a:solidFill>
+                  <a:srgbClr val="ECF5FF"/>
+                </a:solidFill>
+                <a:latin typeface="Aptos"/>
+              </a:rPr>
+              <a:t>✓ Title matches mapping</a:t>
+            </a:r>
+          </a:p>
+          <a:p>
+            <a:r>
+              <a:rPr sz="1400">
+                <a:solidFill>
+                  <a:srgbClr val="ECF5FF"/>
+                </a:solidFill>
+                <a:latin typeface="Aptos"/>
+              </a:rPr>
+              <a:t>✓ Secret in Password field</a:t>
+            </a:r>
+          </a:p>
+          <a:p>
+            <a:r>
+              <a:rPr sz="1400">
+                <a:solidFill>
+                  <a:srgbClr val="ECF5FF"/>
+                </a:solidFill>
+                <a:latin typeface="Aptos"/>
+              </a:rPr>
+              <a:t>✓ Dates in YYYY-MM-DD</a:t>
+            </a:r>
+          </a:p>
+          <a:p>
+            <a:r>
+              <a:rPr sz="1400">
+                <a:solidFill>
+                  <a:srgbClr val="ECF5FF"/>
+                </a:solidFill>
+                <a:latin typeface="Aptos"/>
+              </a:rPr>
+              <a:t>✓ rotation_url present</a:t>
+            </a:r>
+          </a:p>
+          <a:p>
+            <a:r>
+              <a:rPr sz="1400">
+                <a:solidFill>
+                  <a:srgbClr val="ECF5FF"/>
+                </a:solidFill>
+                <a:latin typeface="Aptos"/>
+              </a:rPr>
+              <a:t>✓ notes explain purpose</a:t>
+            </a:r>
+          </a:p>
+        </p:txBody>
+      </p:sp>
+    </p:spTree>
+  </p:cSld>
+  <p:clrMapOvr>
+    <a:masterClrMapping/>
+  </p:clrMapOvr>
+</p:sld>
+</file>
+
+<file path=ppt/slides/slide7.xml><?xml version="1.0" encoding="utf-8"?>
+<p:sld xmlns:a="http://schemas.openxmlformats.org/drawingml/2006/main" xmlns:p="http://schemas.openxmlformats.org/presentationml/2006/main" xmlns:r="http://schemas.openxmlformats.org/officeDocument/2006/relationships">
+  <p:cSld>
+    <p:spTree>
+      <p:nvGrpSpPr>
+        <p:cNvPr id="1" name=""/>
+        <p:cNvGrpSpPr/>
+        <p:nvPr/>
+      </p:nvGrpSpPr>
+      <p:grpSpPr/>
+      <p:sp>
+        <p:nvSpPr>
+          <p:cNvPr id="2" name="Rectangle 1"/>
+          <p:cNvSpPr/>
+          <p:nvPr/>
+        </p:nvSpPr>
+        <p:spPr>
+          <a:xfrm>
+            <a:off x="0" y="0"/>
+            <a:ext cx="12191695" cy="6858000"/>
+          </a:xfrm>
+          <a:prstGeom prst="rect">
+            <a:avLst/>
+          </a:prstGeom>
+          <a:solidFill>
+            <a:srgbClr val="020B2A"/>
+          </a:solidFill>
+          <a:ln>
+            <a:noFill/>
+          </a:ln>
+        </p:spPr>
+        <p:style>
+          <a:lnRef idx="1">
+            <a:schemeClr val="accent1"/>
+          </a:lnRef>
+          <a:fillRef idx="3">
+            <a:schemeClr val="accent1"/>
+          </a:fillRef>
+          <a:effectRef idx="2">
+            <a:schemeClr val="accent1"/>
+          </a:effectRef>
+          <a:fontRef idx="minor">
+            <a:schemeClr val="lt1"/>
+          </a:fontRef>
+        </p:style>
+        <p:txBody>
+          <a:bodyPr rtlCol="0" anchor="ctr"/>
+          <a:lstStyle/>
+          <a:p>
+            <a:pPr algn="ctr"/>
+          </a:p>
+        </p:txBody>
+      </p:sp>
+      <p:sp>
+        <p:nvSpPr>
+          <p:cNvPr id="3" name="Rectangle 2"/>
+          <p:cNvSpPr/>
+          <p:nvPr/>
+        </p:nvSpPr>
+        <p:spPr>
+          <a:xfrm>
+            <a:off x="0" y="0"/>
+            <a:ext cx="12191695" cy="54864"/>
+          </a:xfrm>
+          <a:prstGeom prst="rect">
+            <a:avLst/>
+          </a:prstGeom>
+          <a:solidFill>
+            <a:srgbClr val="38BDF8"/>
+          </a:solidFill>
+          <a:ln>
+            <a:noFill/>
+          </a:ln>
+        </p:spPr>
+        <p:style>
+          <a:lnRef idx="1">
+            <a:schemeClr val="accent1"/>
+          </a:lnRef>
+          <a:fillRef idx="3">
+            <a:schemeClr val="accent1"/>
+          </a:fillRef>
+          <a:effectRef idx="2">
+            <a:schemeClr val="accent1"/>
+          </a:effectRef>
+          <a:fontRef idx="minor">
+            <a:schemeClr val="lt1"/>
+          </a:fontRef>
+        </p:style>
+        <p:txBody>
+          <a:bodyPr rtlCol="0" anchor="ctr"/>
+          <a:lstStyle/>
+          <a:p>
+            <a:pPr algn="ctr"/>
+          </a:p>
+        </p:txBody>
+      </p:sp>
+      <p:sp>
+        <p:nvSpPr>
+          <p:cNvPr id="4" name="Rectangle 3"/>
+          <p:cNvSpPr/>
+          <p:nvPr/>
+        </p:nvSpPr>
+        <p:spPr>
+          <a:xfrm>
+            <a:off x="0" y="54864"/>
+            <a:ext cx="12191695" cy="27432"/>
+          </a:xfrm>
+          <a:prstGeom prst="rect">
+            <a:avLst/>
+          </a:prstGeom>
+          <a:solidFill>
+            <a:srgbClr val="A855F7"/>
+          </a:solidFill>
+          <a:ln>
+            <a:noFill/>
+          </a:ln>
+        </p:spPr>
+        <p:style>
+          <a:lnRef idx="1">
+            <a:schemeClr val="accent1"/>
+          </a:lnRef>
+          <a:fillRef idx="3">
+            <a:schemeClr val="accent1"/>
+          </a:fillRef>
+          <a:effectRef idx="2">
+            <a:schemeClr val="accent1"/>
+          </a:effectRef>
+          <a:fontRef idx="minor">
+            <a:schemeClr val="lt1"/>
+          </a:fontRef>
+        </p:style>
+        <p:txBody>
+          <a:bodyPr rtlCol="0" anchor="ctr"/>
+          <a:lstStyle/>
+          <a:p>
+            <a:pPr algn="ctr"/>
+          </a:p>
+        </p:txBody>
+      </p:sp>
+      <p:sp>
+        <p:nvSpPr>
+          <p:cNvPr id="5" name="TextBox 4"/>
+          <p:cNvSpPr txBox="1"/>
+          <p:nvPr/>
+        </p:nvSpPr>
+        <p:spPr>
+          <a:xfrm>
+            <a:off x="438912" y="219456"/>
+            <a:ext cx="11430000" cy="841248"/>
+          </a:xfrm>
+          <a:prstGeom prst="rect">
+            <a:avLst/>
+          </a:prstGeom>
+          <a:noFill/>
+        </p:spPr>
+        <p:txBody>
+          <a:bodyPr wrap="none">
+            <a:spAutoFit/>
+          </a:bodyPr>
+          <a:lstStyle/>
+          <a:p>
+            <a:r>
+              <a:rPr sz="2800">
+                <a:solidFill>
+                  <a:srgbClr val="ECF5FF"/>
+                </a:solidFill>
+                <a:latin typeface="Aptos Display"/>
+              </a:rPr>
+              <a:t>Metadata field options (pick one per line)</a:t>
+            </a:r>
+          </a:p>
+        </p:txBody>
+      </p:sp>
+      <p:sp>
+        <p:nvSpPr>
+          <p:cNvPr id="6" name="Rectangle 5"/>
+          <p:cNvSpPr/>
+          <p:nvPr/>
+        </p:nvSpPr>
+        <p:spPr>
+          <a:xfrm>
+            <a:off x="502920" y="1325880"/>
+            <a:ext cx="5623560" cy="4892040"/>
+          </a:xfrm>
+          <a:prstGeom prst="rect">
+            <a:avLst/>
+          </a:prstGeom>
+          <a:solidFill>
+            <a:srgbClr val="17244A"/>
+          </a:solidFill>
+          <a:ln w="19050">
+            <a:solidFill>
+              <a:srgbClr val="38BDF8"/>
+            </a:solidFill>
+          </a:ln>
+        </p:spPr>
+        <p:style>
+          <a:lnRef idx="1">
+            <a:schemeClr val="accent1"/>
+          </a:lnRef>
+          <a:fillRef idx="3">
+            <a:schemeClr val="accent1"/>
+          </a:fillRef>
+          <a:effectRef idx="2">
+            <a:schemeClr val="accent1"/>
+          </a:effectRef>
+          <a:fontRef idx="minor">
+            <a:schemeClr val="lt1"/>
+          </a:fontRef>
+        </p:style>
+        <p:txBody>
+          <a:bodyPr rtlCol="0" anchor="ctr"/>
+          <a:lstStyle/>
+          <a:p>
+            <a:pPr algn="ctr"/>
+            <a:r>
+              <a:rPr sz="1600" b="1">
+                <a:solidFill>
+                  <a:srgbClr val="4ADE80"/>
+                </a:solidFill>
+                <a:latin typeface="Aptos"/>
+              </a:rPr>
+              <a:t>Identity fields:</a:t>
+            </a:r>
+          </a:p>
+          <a:p>
+            <a:r>
+              <a:rPr sz="1600">
+                <a:solidFill>
+                  <a:srgbClr val="ECF5FF"/>
+                </a:solidFill>
+                <a:latin typeface="Aptos"/>
+              </a:rPr>
+              <a:t>owner: your_name | team_name</a:t>
+            </a:r>
+          </a:p>
+          <a:p>
+            <a:r>
+              <a:rPr sz="1600">
+                <a:solidFill>
+                  <a:srgbClr val="ECF5FF"/>
+                </a:solidFill>
+                <a:latin typeface="Aptos"/>
+              </a:rPr>
+              <a:t>system: hermes | fabric | sim</a:t>
+            </a:r>
+          </a:p>
+          <a:p>
+            <a:r>
+              <a:rPr sz="1600">
+                <a:solidFill>
+                  <a:srgbClr val="ECF5FF"/>
+                </a:solidFill>
+                <a:latin typeface="Aptos"/>
+              </a:rPr>
+              <a:t>environment: dev | staging | prod | shared</a:t>
+            </a:r>
+          </a:p>
+          <a:p>
+            <a:r>
+              <a:rPr sz="1600">
+                <a:solidFill>
+                  <a:srgbClr val="ECF5FF"/>
+                </a:solidFill>
+                <a:latin typeface="Aptos"/>
+              </a:rPr>
+              <a:t/>
+            </a:r>
+          </a:p>
+          <a:p>
+            <a:r>
+              <a:rPr sz="1600">
+                <a:solidFill>
+                  <a:srgbClr val="4ADE80"/>
+                </a:solidFill>
+                <a:latin typeface="Aptos"/>
+              </a:rPr>
+              <a:t>Secret type options:</a:t>
+            </a:r>
+          </a:p>
+          <a:p>
+            <a:r>
+              <a:rPr sz="1600">
+                <a:solidFill>
+                  <a:srgbClr val="ECF5FF"/>
+                </a:solidFill>
+                <a:latin typeface="Aptos"/>
+              </a:rPr>
+              <a:t>api_key | db_password | token</a:t>
+            </a:r>
+          </a:p>
+          <a:p>
+            <a:r>
+              <a:rPr sz="1600">
+                <a:solidFill>
+                  <a:srgbClr val="ECF5FF"/>
+                </a:solidFill>
+                <a:latin typeface="Aptos"/>
+              </a:rPr>
+              <a:t>jwt_secret | encryption_key</a:t>
+            </a:r>
+          </a:p>
+        </p:txBody>
+      </p:sp>
+      <p:sp>
+        <p:nvSpPr>
+          <p:cNvPr id="7" name="Rectangle 6"/>
+          <p:cNvSpPr/>
+          <p:nvPr/>
+        </p:nvSpPr>
+        <p:spPr>
+          <a:xfrm>
+            <a:off x="6355080" y="1325880"/>
+            <a:ext cx="5303520" cy="4892040"/>
+          </a:xfrm>
+          <a:prstGeom prst="rect">
+            <a:avLst/>
+          </a:prstGeom>
+          <a:solidFill>
+            <a:srgbClr val="17244A"/>
+          </a:solidFill>
+          <a:ln w="19050">
+            <a:solidFill>
+              <a:srgbClr val="A855F7"/>
+            </a:solidFill>
+          </a:ln>
+        </p:spPr>
+        <p:style>
+          <a:lnRef idx="1">
+            <a:schemeClr val="accent1"/>
+          </a:lnRef>
+          <a:fillRef idx="3">
+            <a:schemeClr val="accent1"/>
+          </a:fillRef>
+          <a:effectRef idx="2">
+            <a:schemeClr val="accent1"/>
+          </a:effectRef>
+          <a:fontRef idx="minor">
+            <a:schemeClr val="lt1"/>
+          </a:fontRef>
+        </p:style>
+        <p:txBody>
+          <a:bodyPr rtlCol="0" anchor="ctr"/>
+          <a:lstStyle/>
+          <a:p>
+            <a:pPr algn="ctr"/>
+            <a:r>
+              <a:rPr sz="1600" b="1">
+                <a:solidFill>
+                  <a:srgbClr val="FACC15"/>
+                </a:solidFill>
+                <a:latin typeface="Aptos"/>
+              </a:rPr>
+              <a:t>Lifecycle fields:</a:t>
+            </a:r>
+          </a:p>
+          <a:p>
+            <a:r>
+              <a:rPr sz="1600">
+                <a:solidFill>
+                  <a:srgbClr val="ECF5FF"/>
+                </a:solidFill>
+                <a:latin typeface="Aptos"/>
+              </a:rPr>
+              <a:t>rotation_url: provider keys URL</a:t>
+            </a:r>
+          </a:p>
+          <a:p>
+            <a:r>
+              <a:rPr sz="1600">
+                <a:solidFill>
+                  <a:srgbClr val="ECF5FF"/>
+                </a:solidFill>
+                <a:latin typeface="Aptos"/>
+              </a:rPr>
+              <a:t>or internal runbook URL</a:t>
+            </a:r>
+          </a:p>
+          <a:p>
+            <a:r>
+              <a:rPr sz="1600">
+                <a:solidFill>
+                  <a:srgbClr val="ECF5FF"/>
+                </a:solidFill>
+                <a:latin typeface="Aptos"/>
+              </a:rPr>
+              <a:t>created_at: YYYY-MM-DD</a:t>
+            </a:r>
+          </a:p>
+          <a:p>
+            <a:r>
+              <a:rPr sz="1600">
+                <a:solidFill>
+                  <a:srgbClr val="ECF5FF"/>
+                </a:solidFill>
+                <a:latin typeface="Aptos"/>
+              </a:rPr>
+              <a:t>last_rotated_at: YYYY-MM-DD</a:t>
+            </a:r>
+          </a:p>
+          <a:p>
+            <a:r>
+              <a:rPr sz="1600">
+                <a:solidFill>
+                  <a:srgbClr val="ECF5FF"/>
+                </a:solidFill>
+                <a:latin typeface="Aptos"/>
+              </a:rPr>
+              <a:t>next_rotation_due: YYYY-MM-DD</a:t>
+            </a:r>
+          </a:p>
+          <a:p>
+            <a:r>
+              <a:rPr sz="1600">
+                <a:solidFill>
+                  <a:srgbClr val="ECF5FF"/>
+                </a:solidFill>
+                <a:latin typeface="Aptos"/>
+              </a:rPr>
+              <a:t>incident_rotation_required: true | false</a:t>
+            </a:r>
+          </a:p>
+          <a:p>
+            <a:r>
+              <a:rPr sz="1600">
+                <a:solidFill>
+                  <a:srgbClr val="ECF5FF"/>
+                </a:solidFill>
+                <a:latin typeface="Aptos"/>
+              </a:rPr>
+              <a:t>notes: purpose + scope + action</a:t>
+            </a:r>
+          </a:p>
+          <a:p>
+            <a:r>
+              <a:rPr sz="1600">
+                <a:solidFill>
+                  <a:srgbClr val="ECF5FF"/>
+                </a:solidFill>
+                <a:latin typeface="Aptos"/>
+              </a:rPr>
+              <a:t/>
+            </a:r>
+          </a:p>
+          <a:p>
+            <a:r>
+              <a:rPr sz="1600">
+                <a:solidFill>
+                  <a:srgbClr val="4ADE80"/>
+                </a:solidFill>
+                <a:latin typeface="Aptos"/>
+              </a:rPr>
+              <a:t>Tip: secret value goes in Password</a:t>
+            </a:r>
+          </a:p>
+          <a:p>
+            <a:r>
+              <a:rPr sz="1600">
+                <a:solidFill>
+                  <a:srgbClr val="ECF5FF"/>
+                </a:solidFill>
+                <a:latin typeface="Aptos"/>
+              </a:rPr>
+              <a:t>field, not in Notes.</a:t>
             </a:r>
           </a:p>
         </p:txBody>

</xml_diff>

<commit_message>
Descope SIM secret mappings from active Varlock project assets
Git note: Removed ERA_SIM_* references from templates/slide deck to align repo with Hermes/Fabric-only runtime scope; SIM path is no longer part of active validation guidance.

Co-Authored-By: Oz <oz-agent@warp.dev>
</commit_message>
<xml_diff>
--- a/docs/secret-template-entry-guide.pptx
+++ b/docs/secret-template-entry-guide.pptx
@@ -3728,7 +3728,7 @@
               </a:defRPr>
             </a:pPr>
             <a:r>
-              <a:t>Example: ERA_SIM_POSTGRES_PASSWORD</a:t>
+              <a:t>Example: ERA_FABRIC_INTERNAL_API_SECRET</a:t>
             </a:r>
           </a:p>
         </p:txBody>
@@ -3806,7 +3806,7 @@
               </a:defRPr>
             </a:pPr>
             <a:r>
-              <a:t>• System-specific keys (sim, etc.) → ERA_&lt;SYSTEM&gt;_&lt;SECRET_NAME&gt;</a:t>
+              <a:t>• System-specific keys (fabric, hermes, etc.) → ERA_&lt;SYSTEM&gt;_&lt;SECRET_NAME&gt;</a:t>
             </a:r>
           </a:p>
           <a:p>
@@ -4227,9 +4227,6 @@
                 </a:solidFill>
               </a:defRPr>
             </a:pPr>
-            <a:r>
-              <a:t>ERA_SIM_POSTGRES_PASSWORD</a:t>
-            </a:r>
           </a:p>
           <a:p>
             <a:pPr>
@@ -4239,9 +4236,6 @@
                 </a:solidFill>
               </a:defRPr>
             </a:pPr>
-            <a:r>
-              <a:t>ERA_SIM_BETTER_AUTH_SECRET</a:t>
-            </a:r>
           </a:p>
           <a:p>
             <a:pPr>
@@ -4251,9 +4245,6 @@
                 </a:solidFill>
               </a:defRPr>
             </a:pPr>
-            <a:r>
-              <a:t>ERA_SIM_ENCRYPTION_KEY</a:t>
-            </a:r>
           </a:p>
         </p:txBody>
       </p:sp>
@@ -4537,38 +4528,14 @@
           <a:p>
             <a:pPr/>
             <a:r>
-              <a:rPr sz="1600">
-                <a:solidFill>
-                  <a:srgbClr val="ECF5FF"/>
-                </a:solidFill>
-                <a:latin typeface="Consolas"/>
-              </a:rPr>
-              <a:t>POSTGRES_PASSWORD=protonPass(pass://Login/ERA_SIM_POSTGRES_PASSWORD/password)</a:t>
+              <a:t>OPENROUTER_API_KEY_FALLBACK=protonPass(pass://Login/ERA_OPENROUTER_API_KEY_FALLBACK/password)</a:t>
             </a:r>
           </a:p>
           <a:p>
             <a:pPr/>
-            <a:r>
-              <a:rPr sz="1600">
-                <a:solidFill>
-                  <a:srgbClr val="ECF5FF"/>
-                </a:solidFill>
-                <a:latin typeface="Consolas"/>
-              </a:rPr>
-              <a:t>BETTER_AUTH_SECRET=protonPass(pass://Login/ERA_SIM_BETTER_AUTH_SECRET/password)</a:t>
-            </a:r>
           </a:p>
           <a:p>
             <a:pPr/>
-            <a:r>
-              <a:rPr sz="1600">
-                <a:solidFill>
-                  <a:srgbClr val="ECF5FF"/>
-                </a:solidFill>
-                <a:latin typeface="Consolas"/>
-              </a:rPr>
-              <a:t>ENCRYPTION_KEY=protonPass(pass://Login/ERA_SIM_ENCRYPTION_KEY/password)</a:t>
-            </a:r>
           </a:p>
           <a:p>
             <a:pPr/>
@@ -5287,9 +5254,6 @@
                 <a:latin typeface="Consolas"/>
               </a:defRPr>
             </a:pPr>
-            <a:r>
-              <a:t>varlock load --path ~/git/cloned/reference/sim</a:t>
-            </a:r>
           </a:p>
         </p:txBody>
       </p:sp>
@@ -6002,13 +5966,7 @@
           </a:p>
           <a:p>
             <a:r>
-              <a:rPr sz="1600">
-                <a:solidFill>
-                  <a:srgbClr val="ECF5FF"/>
-                </a:solidFill>
-                <a:latin typeface="Aptos"/>
-              </a:rPr>
-              <a:t>system: hermes | fabric | sim</a:t>
+              <a:t>system: hermes | fabric</a:t>
             </a:r>
           </a:p>
           <a:p>

</xml_diff>